<commit_message>
Regenerate decks with html2pptx for flow slides
- Add presentation/html-flow HTML slides and build-flow-html2pptx.js
- Refresh cumulative commit chart through 2026-05-11 (13 commits)
- Document html2pptx path and PPTX_HTML2PPTX_SCRIPTS override

Co-authored-by: Cursor <cursoragent@cursor.com>
</commit_message>
<xml_diff>
--- a/presentation/usd-simready-inspector-nvidia-template.pptx
+++ b/presentation/usd-simready-inspector-nvidia-template.pptx
@@ -355,9 +355,9 @@
           </c:marker>
           <c:cat>
             <c:strRef>
-              <c:f>Sheet1!$A$2:$A$6</c:f>
+              <c:f>Sheet1!$A$2:$A$7</c:f>
               <c:strCache>
-                <c:ptCount val="5"/>
+                <c:ptCount val="6"/>
                 <c:pt idx="0">
                   <c:v>2026-04-15</c:v>
                 </c:pt>
@@ -373,15 +373,18 @@
                 <c:pt idx="4">
                   <c:v>2026-05-09</c:v>
                 </c:pt>
+                <c:pt idx="5">
+                  <c:v>2026-05-11</c:v>
+                </c:pt>
               </c:strCache>
             </c:strRef>
           </c:cat>
           <c:val>
             <c:numRef>
-              <c:f>Sheet1!$B$2:$B$6</c:f>
+              <c:f>Sheet1!$B$2:$B$7</c:f>
               <c:numCache>
                 <c:formatCode>General</c:formatCode>
-                <c:ptCount val="5"/>
+                <c:ptCount val="6"/>
                 <c:pt idx="0">
                   <c:v>2</c:v>
                 </c:pt>
@@ -396,6 +399,9 @@
                 </c:pt>
                 <c:pt idx="4">
                   <c:v>12</c:v>
+                </c:pt>
+                <c:pt idx="5">
+                  <c:v>13</c:v>
                 </c:pt>
               </c:numCache>
             </c:numRef>
@@ -529,7 +535,7 @@
         <c:axId val="488380464"/>
         <c:scaling>
           <c:orientation val="minMax"/>
-          <c:max val="14.0"/>
+          <c:max val="16.0"/>
           <c:min val="0.0"/>
         </c:scaling>
         <c:delete val="0"/>

</xml_diff>